<commit_message>
Atualiza dados, graficos, relatorio e slides com medicao deterministica
- Nova medicao na mesma maquina com entradas deterministicas identicas Python/Java
- Adiciona CSVs brutos (270 medicoes por linguagem) alem dos resumos
- Regenera os 4 graficos com os dados novos
- Relatorio e slides: tabelas atualizadas, speedup 38x-70x, e nova analise do
  Java (a anomalia 'pior mais rapido' sumiu; caso medio passou a ser o mais lento
  por menor previsibilidade de branch/cache sobre alfabeto variado)
</commit_message>
<xml_diff>
--- a/slides/KMP_Apresentação.pptx
+++ b/slides/KMP_Apresentação.pptx
@@ -2480,7 +2480,7 @@
                 <a:ea typeface="Georgia" pitchFamily="34" charset="-122"/>
                 <a:cs typeface="Georgia" pitchFamily="34" charset="-120"/>
               </a:rPr>
-              <a:t>≈ 34×</a:t>
+              <a:t>≈ 38×</a:t>
             </a:r>
             <a:endParaRPr lang="en-US" sz="4000" dirty="0"/>
           </a:p>
@@ -2595,7 +2595,7 @@
                 <a:ea typeface="Georgia" pitchFamily="34" charset="-122"/>
                 <a:cs typeface="Georgia" pitchFamily="34" charset="-120"/>
               </a:rPr>
-              <a:t>≈ 79×</a:t>
+              <a:t>≈ 50×</a:t>
             </a:r>
             <a:endParaRPr lang="en-US" sz="4000" dirty="0"/>
           </a:p>
@@ -4748,7 +4748,7 @@
                 <a:ea typeface="Calibri" pitchFamily="34" charset="-122"/>
                 <a:cs typeface="Calibri" pitchFamily="34" charset="-120"/>
               </a:rPr>
-              <a:t>Java foi 34×–79× mais rápido que Python para n = 100.000.</a:t>
+              <a:t>Java foi 38×–70× mais rápido que Python para n = 100.000.</a:t>
             </a:r>
             <a:endParaRPr lang="en-US" sz="1700" dirty="0"/>
           </a:p>
@@ -11066,7 +11066,7 @@
                           <a:ea typeface="Calibri" pitchFamily="34" charset="-122"/>
                           <a:cs typeface="Calibri" pitchFamily="34" charset="-120"/>
                         </a:rPr>
-                        <a:t>77,32 ± 13,07</a:t>
+                        <a:t>74,63 ± 10,19</a:t>
                       </a:r>
                       <a:endParaRPr lang="en-US" sz="1500" dirty="0">
                         <a:latin typeface="Calibri" charset="0"/>
@@ -11134,7 +11134,7 @@
                           <a:ea typeface="Calibri" pitchFamily="34" charset="-122"/>
                           <a:cs typeface="Calibri" pitchFamily="34" charset="-120"/>
                         </a:rPr>
-                        <a:t>782,98 ± 79,04</a:t>
+                        <a:t>799,20 ± 108,18</a:t>
                       </a:r>
                       <a:endParaRPr lang="en-US" sz="1500" dirty="0">
                         <a:latin typeface="Calibri" charset="0"/>
@@ -11202,7 +11202,7 @@
                           <a:ea typeface="Calibri" pitchFamily="34" charset="-122"/>
                           <a:cs typeface="Calibri" pitchFamily="34" charset="-120"/>
                         </a:rPr>
-                        <a:t>7.851,24 ± 284,85</a:t>
+                        <a:t>8.003,94 ± 1.091,06</a:t>
                       </a:r>
                       <a:endParaRPr lang="en-US" sz="1500" dirty="0">
                         <a:latin typeface="Calibri" charset="0"/>
@@ -11340,7 +11340,7 @@
                           <a:ea typeface="Calibri" pitchFamily="34" charset="-122"/>
                           <a:cs typeface="Calibri" pitchFamily="34" charset="-120"/>
                         </a:rPr>
-                        <a:t>77,60 ± 14,85</a:t>
+                        <a:t>101,30 ± 86,30</a:t>
                       </a:r>
                       <a:endParaRPr lang="en-US" sz="1500" dirty="0">
                         <a:latin typeface="Calibri" charset="0"/>
@@ -11408,7 +11408,7 @@
                           <a:ea typeface="Calibri" pitchFamily="34" charset="-122"/>
                           <a:cs typeface="Calibri" pitchFamily="34" charset="-120"/>
                         </a:rPr>
-                        <a:t>779,99 ± 48,64</a:t>
+                        <a:t>806,87 ± 123,45</a:t>
                       </a:r>
                       <a:endParaRPr lang="en-US" sz="1500" dirty="0">
                         <a:latin typeface="Calibri" charset="0"/>
@@ -11476,7 +11476,7 @@
                           <a:ea typeface="Calibri" pitchFamily="34" charset="-122"/>
                           <a:cs typeface="Calibri" pitchFamily="34" charset="-120"/>
                         </a:rPr>
-                        <a:t>7.786,46 ± 316,21</a:t>
+                        <a:t>9.515,19 ± 3.397,53</a:t>
                       </a:r>
                       <a:endParaRPr lang="en-US" sz="1500" dirty="0">
                         <a:latin typeface="Calibri" charset="0"/>
@@ -11614,7 +11614,7 @@
                           <a:ea typeface="Calibri" pitchFamily="34" charset="-122"/>
                           <a:cs typeface="Calibri" pitchFamily="34" charset="-120"/>
                         </a:rPr>
-                        <a:t>90,32 ± 11,27</a:t>
+                        <a:t>101,58 ± 12,82</a:t>
                       </a:r>
                       <a:endParaRPr lang="en-US" sz="1500" dirty="0">
                         <a:latin typeface="Calibri" charset="0"/>
@@ -11682,7 +11682,7 @@
                           <a:ea typeface="Calibri" pitchFamily="34" charset="-122"/>
                           <a:cs typeface="Calibri" pitchFamily="34" charset="-120"/>
                         </a:rPr>
-                        <a:t>947,90 ± 162,32</a:t>
+                        <a:t>1.024,84 ± 159,15</a:t>
                       </a:r>
                       <a:endParaRPr lang="en-US" sz="1500" dirty="0">
                         <a:latin typeface="Calibri" charset="0"/>
@@ -11750,7 +11750,7 @@
                           <a:ea typeface="Calibri" pitchFamily="34" charset="-122"/>
                           <a:cs typeface="Calibri" pitchFamily="34" charset="-120"/>
                         </a:rPr>
-                        <a:t>10.714,53 ± 345,39</a:t>
+                        <a:t>11.194,91 ± 603,50</a:t>
                       </a:r>
                       <a:endParaRPr lang="en-US" sz="1500" dirty="0">
                         <a:latin typeface="Calibri" charset="0"/>
@@ -11881,7 +11881,7 @@
                 <a:ea typeface="Calibri" pitchFamily="34" charset="-122"/>
                 <a:cs typeface="Calibri" pitchFamily="34" charset="-120"/>
               </a:rPr>
-              <a:t>Melhor ≈ Médio; Pior ≈ 1,37× mais lento (constante do retrocesso via LPS).</a:t>
+              <a:t>Ordem esperada: melhor &lt; médio &lt; pior; o pior é ≈ 1,40× mais lento que o melhor (retrocesso via LPS).</a:t>
             </a:r>
             <a:endParaRPr lang="en-US" sz="1400" dirty="0"/>
           </a:p>
@@ -12385,7 +12385,7 @@
                           <a:ea typeface="Calibri" pitchFamily="34" charset="-122"/>
                           <a:cs typeface="Calibri" pitchFamily="34" charset="-120"/>
                         </a:rPr>
-                        <a:t>20,98 ± 3,64</a:t>
+                        <a:t>21,72 ± 1,23</a:t>
                       </a:r>
                       <a:endParaRPr lang="en-US" sz="1500" dirty="0">
                         <a:latin typeface="Calibri" charset="0"/>
@@ -12453,7 +12453,7 @@
                           <a:ea typeface="Calibri" pitchFamily="34" charset="-122"/>
                           <a:cs typeface="Calibri" pitchFamily="34" charset="-120"/>
                         </a:rPr>
-                        <a:t>48,23 ± 11,68</a:t>
+                        <a:t>51,12 ± 11,93</a:t>
                       </a:r>
                       <a:endParaRPr lang="en-US" sz="1500" dirty="0">
                         <a:latin typeface="Calibri" charset="0"/>
@@ -12521,7 +12521,7 @@
                           <a:ea typeface="Calibri" pitchFamily="34" charset="-122"/>
                           <a:cs typeface="Calibri" pitchFamily="34" charset="-120"/>
                         </a:rPr>
-                        <a:t>111,33 ± 42,14</a:t>
+                        <a:t>114,73 ± 28,69</a:t>
                       </a:r>
                       <a:endParaRPr lang="en-US" sz="1500" dirty="0">
                         <a:latin typeface="Calibri" charset="0"/>
@@ -12659,7 +12659,7 @@
                           <a:ea typeface="Calibri" pitchFamily="34" charset="-122"/>
                           <a:cs typeface="Calibri" pitchFamily="34" charset="-120"/>
                         </a:rPr>
-                        <a:t>7,41 ± 6,81</a:t>
+                        <a:t>8,67 ± 7,91</a:t>
                       </a:r>
                       <a:endParaRPr lang="en-US" sz="1500" dirty="0">
                         <a:latin typeface="Calibri" charset="0"/>
@@ -12727,7 +12727,7 @@
                           <a:ea typeface="Calibri" pitchFamily="34" charset="-122"/>
                           <a:cs typeface="Calibri" pitchFamily="34" charset="-120"/>
                         </a:rPr>
-                        <a:t>58,97 ± 15,76</a:t>
+                        <a:t>69,12 ± 44,58</a:t>
                       </a:r>
                       <a:endParaRPr lang="en-US" sz="1500" dirty="0">
                         <a:latin typeface="Calibri" charset="0"/>
@@ -12795,7 +12795,7 @@
                           <a:ea typeface="Calibri" pitchFamily="34" charset="-122"/>
                           <a:cs typeface="Calibri" pitchFamily="34" charset="-120"/>
                         </a:rPr>
-                        <a:t>231,04 ± 10,98</a:t>
+                        <a:t>250,86 ± 36,36</a:t>
                       </a:r>
                       <a:endParaRPr lang="en-US" sz="1500" dirty="0">
                         <a:latin typeface="Calibri" charset="0"/>
@@ -12933,7 +12933,7 @@
                           <a:ea typeface="Calibri" pitchFamily="34" charset="-122"/>
                           <a:cs typeface="Calibri" pitchFamily="34" charset="-120"/>
                         </a:rPr>
-                        <a:t>1,44 ± 0,06</a:t>
+                        <a:t>10,40 ± 8,09</a:t>
                       </a:r>
                       <a:endParaRPr lang="en-US" sz="1500" dirty="0">
                         <a:latin typeface="Calibri" charset="0"/>
@@ -13001,7 +13001,7 @@
                           <a:ea typeface="Calibri" pitchFamily="34" charset="-122"/>
                           <a:cs typeface="Calibri" pitchFamily="34" charset="-120"/>
                         </a:rPr>
-                        <a:t>14,40 ± 1,78</a:t>
+                        <a:t>84,45 ± 43,69</a:t>
                       </a:r>
                       <a:endParaRPr lang="en-US" sz="1500" dirty="0">
                         <a:latin typeface="Calibri" charset="0"/>
@@ -13069,7 +13069,7 @@
                           <a:ea typeface="Calibri" pitchFamily="34" charset="-122"/>
                           <a:cs typeface="Calibri" pitchFamily="34" charset="-120"/>
                         </a:rPr>
-                        <a:t>135,51 ± 10,72</a:t>
+                        <a:t>222,30 ± 37,44</a:t>
                       </a:r>
                       <a:endParaRPr lang="en-US" sz="1500" dirty="0">
                         <a:latin typeface="Calibri" charset="0"/>
@@ -13158,7 +13158,7 @@
                 <a:ea typeface="Calibri" pitchFamily="34" charset="-122"/>
                 <a:cs typeface="Calibri" pitchFamily="34" charset="-120"/>
               </a:rPr>
-              <a:t>Anomalia: o "pior caso" foi o mais rápido. </a:t>
+              <a:t>Com entradas idênticas às do Python, </a:t>
             </a:r>
             <a:pPr indent="0" marL="0">
               <a:buNone/>
@@ -13172,35 +13172,21 @@
                 <a:ea typeface="Calibri" pitchFamily="34" charset="-122"/>
                 <a:cs typeface="Calibri" pitchFamily="34" charset="-120"/>
               </a:rPr>
-              <a:t>Causas combinadas — (1) entradas de caractere único geram branch prediction e cache quase perfeitos; (2) os 3 casos rodam na mesma JVM em ordem fixa, então o JIT esquenta progressivamente (melhor roda interpretado, pior roda compilado). </a:t>
+              <a:t>o pior caso agora supera corretamente o melhor — a anomalia anterior sumiu. O caso médio virou o mais lento: seu alfabeto variado gera comparações reais e desvios pouco previsíveis (branch prediction e cache piores), enquanto melhor e pior usam texto de um único caractere. </a:t>
             </a:r>
             <a:pPr indent="0" marL="0">
               <a:buNone/>
             </a:pPr>
             <a:r>
-              <a:rPr lang="en-US" sz="1400" b="1" dirty="0">
-                <a:solidFill>
-                  <a:srgbClr val="1E2761"/>
+              <a:rPr lang="en-US" sz="1400" dirty="0">
+                <a:solidFill>
+                  <a:srgbClr val="2B2B2B"/>
                 </a:solidFill>
                 <a:latin typeface="Calibri" pitchFamily="34" charset="0"/>
                 <a:ea typeface="Calibri" pitchFamily="34" charset="-122"/>
                 <a:cs typeface="Calibri" pitchFamily="34" charset="-120"/>
               </a:rPr>
-              <a:t>Limitação: </a:t>
-            </a:r>
-            <a:pPr indent="0" marL="0">
-              <a:buNone/>
-            </a:pPr>
-            <a:r>
-              <a:rPr lang="en-US" sz="1400" dirty="0">
-                <a:solidFill>
-                  <a:srgbClr val="2B2B2B"/>
-                </a:solidFill>
-                <a:latin typeface="Calibri" pitchFamily="34" charset="0"/>
-                <a:ea typeface="Calibri" pitchFamily="34" charset="-122"/>
-                <a:cs typeface="Calibri" pitchFamily="34" charset="-120"/>
-              </a:rPr>
-              <a:t>isolar cada caso em JVM separada (ex.: JMH) tornaria a comparação entre casos mais justa. O crescimento permanece O(n+m).</a:t>
+              <a:t>Tempos em µs são sensíveis a ruído — daí os desvios altos em n pequeno. Crescimento O(n+m).</a:t>
             </a:r>
             <a:endParaRPr lang="en-US" sz="1400" dirty="0"/>
           </a:p>

</xml_diff>